<commit_message>
Updated poster with feedback fixes
Co-authored-by: Copilot <copilot@github.com>
</commit_message>
<xml_diff>
--- a/docs/poster/FionnMcGoldrick_FYP_Poster.pptx
+++ b/docs/poster/FionnMcGoldrick_FYP_Poster.pptx
@@ -24770,7 +24770,7 @@
                 </a:solidFill>
                 <a:latin typeface="Arial Black" panose="020B0604020202020204" pitchFamily="34" charset="0"/>
               </a:rPr>
-              <a:t>An AI-Driven Platform for Adaptive Code Assessment and Gamified Leaning</a:t>
+              <a:t>An AI-Driven Platform for Adaptive Code Assessment and Gamified Learning</a:t>
             </a:r>
           </a:p>
           <a:p>
@@ -26062,7 +26062,7 @@
         </p:nvCxnSpPr>
         <p:spPr bwMode="auto">
           <a:xfrm>
-            <a:off x="953540" y="9616619"/>
+            <a:off x="1014834" y="9423648"/>
             <a:ext cx="8668018" cy="0"/>
           </a:xfrm>
           <a:prstGeom prst="line">
@@ -26708,7 +26708,7 @@
         </p:blipFill>
         <p:spPr bwMode="auto">
           <a:xfrm>
-            <a:off x="3510538" y="14657595"/>
+            <a:off x="3506247" y="14668363"/>
             <a:ext cx="929354" cy="929354"/>
           </a:xfrm>
           <a:prstGeom prst="rect">
@@ -27998,7 +27998,7 @@
         </p:nvSpPr>
         <p:spPr>
           <a:xfrm>
-            <a:off x="4512136" y="22748335"/>
+            <a:off x="4539080" y="22936704"/>
             <a:ext cx="5374421" cy="2862322"/>
           </a:xfrm>
           <a:prstGeom prst="rect">
@@ -28442,26 +28442,21 @@
               <a:buChar char="•"/>
             </a:pPr>
             <a:r>
-              <a:rPr lang="en-GB" sz="3600" dirty="0">
+              <a:rPr lang="en-IE" sz="3600" dirty="0">
+                <a:solidFill>
+                  <a:schemeClr val="bg1"/>
+                </a:solidFill>
+              </a:rPr>
+              <a:t>Question </a:t>
+            </a:r>
+            <a:r>
+              <a:rPr lang="en-IE" sz="3600" dirty="0">
                 <a:solidFill>
                   <a:srgbClr val="FF9500"/>
                 </a:solidFill>
               </a:rPr>
-              <a:t>progress tracker, </a:t>
-            </a:r>
-            <a:r>
-              <a:rPr lang="en-GB" sz="3600" dirty="0">
-                <a:solidFill>
-                  <a:schemeClr val="bg1"/>
-                </a:solidFill>
-              </a:rPr>
-              <a:t>top of screen</a:t>
-            </a:r>
-            <a:endParaRPr lang="en-IE" sz="2800" dirty="0">
-              <a:solidFill>
-                <a:schemeClr val="bg1"/>
-              </a:solidFill>
-            </a:endParaRPr>
+              <a:t>progress tracker</a:t>
+            </a:r>
           </a:p>
         </p:txBody>
       </p:sp>
@@ -29116,7 +29111,7 @@
         </p:blipFill>
         <p:spPr>
           <a:xfrm>
-            <a:off x="15528194" y="15714807"/>
+            <a:off x="15528194" y="15586949"/>
             <a:ext cx="1464346" cy="1464346"/>
           </a:xfrm>
           <a:prstGeom prst="rect">
@@ -29198,8 +29193,8 @@
         </p:nvSpPr>
         <p:spPr>
           <a:xfrm>
-            <a:off x="17109422" y="16218852"/>
-            <a:ext cx="2555508" cy="400110"/>
+            <a:off x="17109422" y="15608556"/>
+            <a:ext cx="1959443" cy="1384995"/>
           </a:xfrm>
           <a:prstGeom prst="rect">
             <a:avLst/>
@@ -29207,13 +29202,13 @@
           <a:noFill/>
         </p:spPr>
         <p:txBody>
-          <a:bodyPr wrap="none" rtlCol="0">
+          <a:bodyPr wrap="square" rtlCol="0">
             <a:spAutoFit/>
           </a:bodyPr>
           <a:lstStyle/>
           <a:p>
             <a:r>
-              <a:rPr lang="en-IE" sz="2000" b="1" dirty="0">
+              <a:rPr lang="en-IE" sz="2800" b="1" dirty="0">
                 <a:solidFill>
                   <a:schemeClr val="bg1"/>
                 </a:solidFill>
@@ -29237,8 +29232,8 @@
         </p:nvSpPr>
         <p:spPr>
           <a:xfrm>
-            <a:off x="15371092" y="17730004"/>
-            <a:ext cx="2662908" cy="707886"/>
+            <a:off x="15147494" y="17302875"/>
+            <a:ext cx="2896394" cy="1384995"/>
           </a:xfrm>
           <a:prstGeom prst="rect">
             <a:avLst/>
@@ -29246,14 +29241,14 @@
           <a:noFill/>
         </p:spPr>
         <p:txBody>
-          <a:bodyPr wrap="none" rtlCol="0">
+          <a:bodyPr wrap="square" rtlCol="0">
             <a:spAutoFit/>
           </a:bodyPr>
           <a:lstStyle/>
           <a:p>
             <a:pPr algn="r"/>
             <a:r>
-              <a:rPr lang="en-IE" sz="2000" b="1" dirty="0">
+              <a:rPr lang="en-IE" sz="2800" b="1" dirty="0">
                 <a:solidFill>
                   <a:schemeClr val="bg1"/>
                 </a:solidFill>
@@ -29264,7 +29259,7 @@
           <a:p>
             <a:pPr algn="r"/>
             <a:r>
-              <a:rPr lang="en-IE" sz="2000" b="1" dirty="0">
+              <a:rPr lang="en-IE" sz="2800" b="1" dirty="0">
                 <a:solidFill>
                   <a:schemeClr val="bg1"/>
                 </a:solidFill>
@@ -29288,8 +29283,8 @@
         </p:nvSpPr>
         <p:spPr>
           <a:xfrm>
-            <a:off x="17208787" y="19389644"/>
-            <a:ext cx="1980421" cy="707886"/>
+            <a:off x="17177344" y="19258897"/>
+            <a:ext cx="2438621" cy="954107"/>
           </a:xfrm>
           <a:prstGeom prst="rect">
             <a:avLst/>
@@ -29303,7 +29298,7 @@
           <a:lstStyle/>
           <a:p>
             <a:r>
-              <a:rPr lang="en-IE" sz="2000" b="1" dirty="0">
+              <a:rPr lang="en-IE" sz="2800" b="1" dirty="0">
                 <a:solidFill>
                   <a:schemeClr val="bg1"/>
                 </a:solidFill>
@@ -29357,8 +29352,8 @@
         </p:nvSpPr>
         <p:spPr>
           <a:xfrm>
-            <a:off x="15639741" y="21047938"/>
-            <a:ext cx="1980421" cy="707886"/>
+            <a:off x="15075080" y="20882085"/>
+            <a:ext cx="2574378" cy="954107"/>
           </a:xfrm>
           <a:prstGeom prst="rect">
             <a:avLst/>
@@ -29373,7 +29368,7 @@
           <a:p>
             <a:pPr algn="r"/>
             <a:r>
-              <a:rPr lang="en-IE" sz="2000" b="1" dirty="0">
+              <a:rPr lang="en-IE" sz="2800" b="1" dirty="0">
                 <a:solidFill>
                   <a:schemeClr val="bg1"/>
                 </a:solidFill>
@@ -29384,7 +29379,7 @@
           <a:p>
             <a:pPr algn="r"/>
             <a:r>
-              <a:rPr lang="en-IE" sz="2000" b="1" dirty="0">
+              <a:rPr lang="en-IE" sz="2800" b="1" dirty="0">
                 <a:solidFill>
                   <a:schemeClr val="bg1"/>
                 </a:solidFill>
@@ -29438,8 +29433,8 @@
         </p:nvSpPr>
         <p:spPr>
           <a:xfrm>
-            <a:off x="17208787" y="23564375"/>
-            <a:ext cx="2315955" cy="1200329"/>
+            <a:off x="17173012" y="23503415"/>
+            <a:ext cx="2608663" cy="1384995"/>
           </a:xfrm>
           <a:prstGeom prst="rect">
             <a:avLst/>
@@ -29457,7 +29452,7 @@
               <a:buChar char="•"/>
             </a:pPr>
             <a:r>
-              <a:rPr lang="en-IE" b="1" dirty="0">
+              <a:rPr lang="en-IE" sz="2800" b="1" dirty="0">
                 <a:solidFill>
                   <a:schemeClr val="bg1"/>
                 </a:solidFill>
@@ -29471,7 +29466,7 @@
               <a:buChar char="•"/>
             </a:pPr>
             <a:r>
-              <a:rPr lang="en-IE" b="1" dirty="0">
+              <a:rPr lang="en-IE" sz="2800" b="1" dirty="0">
                 <a:solidFill>
                   <a:schemeClr val="bg1"/>
                 </a:solidFill>
@@ -29485,7 +29480,7 @@
               <a:buChar char="•"/>
             </a:pPr>
             <a:r>
-              <a:rPr lang="en-IE" b="1" dirty="0">
+              <a:rPr lang="en-IE" sz="2800" b="1" dirty="0">
                 <a:solidFill>
                   <a:schemeClr val="bg1"/>
                 </a:solidFill>
@@ -30760,7 +30755,7 @@
                   <a:srgbClr val="FF9500"/>
                 </a:solidFill>
               </a:rPr>
-              <a:t>13 classes</a:t>
+              <a:t>10 classes</a:t>
             </a:r>
             <a:endParaRPr lang="en-IE" sz="2800" dirty="0">
               <a:solidFill>
@@ -31393,10 +31388,168 @@
       </p:sp>
       <p:sp>
         <p:nvSpPr>
-          <p:cNvPr id="5965" name="Rectangle 5964">
+          <p:cNvPr id="5969" name="Rectangle 5968">
             <a:extLst>
               <a:ext uri="{FF2B5EF4-FFF2-40B4-BE49-F238E27FC236}">
-                <a16:creationId xmlns:a16="http://schemas.microsoft.com/office/drawing/2014/main" id="{18DFB2F4-8E85-577F-C79B-2B61A2B6C96C}"/>
+                <a16:creationId xmlns:a16="http://schemas.microsoft.com/office/drawing/2014/main" id="{678DBDB7-D50A-C822-E646-6184D1878689}"/>
+              </a:ext>
+            </a:extLst>
+          </p:cNvPr>
+          <p:cNvSpPr/>
+          <p:nvPr/>
+        </p:nvSpPr>
+        <p:spPr bwMode="auto">
+          <a:xfrm>
+            <a:off x="23778767" y="10065532"/>
+            <a:ext cx="1037944" cy="523220"/>
+          </a:xfrm>
+          <a:prstGeom prst="rect">
+            <a:avLst/>
+          </a:prstGeom>
+          <a:solidFill>
+            <a:srgbClr val="262626"/>
+          </a:solidFill>
+          <a:ln w="9525" cap="flat" cmpd="sng" algn="ctr">
+            <a:solidFill>
+              <a:srgbClr val="FF9500"/>
+            </a:solidFill>
+            <a:prstDash val="solid"/>
+            <a:round/>
+            <a:headEnd type="none" w="med" len="med"/>
+            <a:tailEnd type="none" w="med" len="med"/>
+          </a:ln>
+          <a:effectLst/>
+        </p:spPr>
+        <p:txBody>
+          <a:bodyPr vert="horz" wrap="square" lIns="91440" tIns="45720" rIns="91440" bIns="45720" numCol="1" rtlCol="0" anchor="t" anchorCtr="0" compatLnSpc="1">
+            <a:prstTxWarp prst="textNoShape">
+              <a:avLst/>
+            </a:prstTxWarp>
+          </a:bodyPr>
+          <a:lstStyle/>
+          <a:p>
+            <a:pPr marL="0" marR="0" indent="0" algn="ctr" defTabSz="3600450" rtl="0" eaLnBrk="1" fontAlgn="base" latinLnBrk="0" hangingPunct="1">
+              <a:lnSpc>
+                <a:spcPct val="100000"/>
+              </a:lnSpc>
+              <a:spcBef>
+                <a:spcPct val="0"/>
+              </a:spcBef>
+              <a:spcAft>
+                <a:spcPct val="0"/>
+              </a:spcAft>
+              <a:buClrTx/>
+              <a:buSzTx/>
+              <a:buFontTx/>
+              <a:buNone/>
+              <a:tabLst/>
+            </a:pPr>
+            <a:r>
+              <a:rPr kumimoji="0" lang="en-IE" sz="2800" b="0" i="0" u="none" strike="noStrike" cap="none" normalizeH="0" baseline="0" dirty="0">
+                <a:ln>
+                  <a:noFill/>
+                </a:ln>
+                <a:solidFill>
+                  <a:schemeClr val="bg1"/>
+                </a:solidFill>
+                <a:effectLst/>
+                <a:latin typeface="Arial Narrow" charset="0"/>
+              </a:rPr>
+              <a:t>Graph</a:t>
+            </a:r>
+            <a:endParaRPr kumimoji="0" lang="en-IE" sz="2400" b="0" i="0" u="none" strike="noStrike" cap="none" normalizeH="0" baseline="0" dirty="0">
+              <a:ln>
+                <a:noFill/>
+              </a:ln>
+              <a:solidFill>
+                <a:schemeClr val="bg1"/>
+              </a:solidFill>
+              <a:effectLst/>
+              <a:latin typeface="Arial Narrow" charset="0"/>
+            </a:endParaRPr>
+          </a:p>
+        </p:txBody>
+      </p:sp>
+      <p:sp>
+        <p:nvSpPr>
+          <p:cNvPr id="5971" name="Rectangle 5970">
+            <a:extLst>
+              <a:ext uri="{FF2B5EF4-FFF2-40B4-BE49-F238E27FC236}">
+                <a16:creationId xmlns:a16="http://schemas.microsoft.com/office/drawing/2014/main" id="{8E82FAE0-E23B-2DA9-60B3-645C76329AC3}"/>
+              </a:ext>
+            </a:extLst>
+          </p:cNvPr>
+          <p:cNvSpPr/>
+          <p:nvPr/>
+        </p:nvSpPr>
+        <p:spPr bwMode="auto">
+          <a:xfrm>
+            <a:off x="24943638" y="10065532"/>
+            <a:ext cx="1037944" cy="523220"/>
+          </a:xfrm>
+          <a:prstGeom prst="rect">
+            <a:avLst/>
+          </a:prstGeom>
+          <a:solidFill>
+            <a:srgbClr val="262626"/>
+          </a:solidFill>
+          <a:ln w="9525" cap="flat" cmpd="sng" algn="ctr">
+            <a:solidFill>
+              <a:srgbClr val="FF9500"/>
+            </a:solidFill>
+            <a:prstDash val="solid"/>
+            <a:round/>
+            <a:headEnd type="none" w="med" len="med"/>
+            <a:tailEnd type="none" w="med" len="med"/>
+          </a:ln>
+          <a:effectLst/>
+        </p:spPr>
+        <p:txBody>
+          <a:bodyPr vert="horz" wrap="square" lIns="91440" tIns="45720" rIns="91440" bIns="45720" numCol="1" rtlCol="0" anchor="ctr" anchorCtr="0" compatLnSpc="1">
+            <a:prstTxWarp prst="textNoShape">
+              <a:avLst/>
+            </a:prstTxWarp>
+          </a:bodyPr>
+          <a:lstStyle/>
+          <a:p>
+            <a:pPr marL="0" marR="0" indent="0" algn="ctr" defTabSz="3600450" rtl="0" eaLnBrk="1" fontAlgn="base" latinLnBrk="0" hangingPunct="1">
+              <a:lnSpc>
+                <a:spcPct val="100000"/>
+              </a:lnSpc>
+              <a:spcBef>
+                <a:spcPct val="0"/>
+              </a:spcBef>
+              <a:spcAft>
+                <a:spcPct val="0"/>
+              </a:spcAft>
+              <a:buClrTx/>
+              <a:buSzTx/>
+              <a:buFontTx/>
+              <a:buNone/>
+              <a:tabLst/>
+            </a:pPr>
+            <a:r>
+              <a:rPr kumimoji="0" lang="en-IE" sz="1600" b="0" i="0" u="none" strike="noStrike" cap="none" normalizeH="0" baseline="0" dirty="0">
+                <a:ln>
+                  <a:noFill/>
+                </a:ln>
+                <a:solidFill>
+                  <a:schemeClr val="bg1"/>
+                </a:solidFill>
+                <a:effectLst/>
+                <a:latin typeface="Arial Narrow" charset="0"/>
+              </a:rPr>
+              <a:t>Linked List</a:t>
+            </a:r>
+          </a:p>
+        </p:txBody>
+      </p:sp>
+      <p:sp>
+        <p:nvSpPr>
+          <p:cNvPr id="5973" name="Rectangle 5972">
+            <a:extLst>
+              <a:ext uri="{FF2B5EF4-FFF2-40B4-BE49-F238E27FC236}">
+                <a16:creationId xmlns:a16="http://schemas.microsoft.com/office/drawing/2014/main" id="{51F712F5-4AB2-7B36-D0C1-FDBABAC0BD55}"/>
               </a:ext>
             </a:extLst>
           </p:cNvPr>
@@ -31450,258 +31603,6 @@
               <a:tabLst/>
             </a:pPr>
             <a:r>
-              <a:rPr kumimoji="0" lang="en-IE" sz="1400" b="0" i="0" u="none" strike="noStrike" cap="none" normalizeH="0" baseline="0" dirty="0">
-                <a:ln>
-                  <a:noFill/>
-                </a:ln>
-                <a:solidFill>
-                  <a:schemeClr val="bg1"/>
-                </a:solidFill>
-                <a:effectLst/>
-                <a:latin typeface="Arial Narrow" charset="0"/>
-              </a:rPr>
-              <a:t>Divide &amp; Conquer</a:t>
-            </a:r>
-            <a:endParaRPr kumimoji="0" lang="en-IE" sz="1200" b="0" i="0" u="none" strike="noStrike" cap="none" normalizeH="0" baseline="0" dirty="0">
-              <a:ln>
-                <a:noFill/>
-              </a:ln>
-              <a:solidFill>
-                <a:schemeClr val="bg1"/>
-              </a:solidFill>
-              <a:effectLst/>
-              <a:latin typeface="Arial Narrow" charset="0"/>
-            </a:endParaRPr>
-          </a:p>
-        </p:txBody>
-      </p:sp>
-      <p:sp>
-        <p:nvSpPr>
-          <p:cNvPr id="5969" name="Rectangle 5968">
-            <a:extLst>
-              <a:ext uri="{FF2B5EF4-FFF2-40B4-BE49-F238E27FC236}">
-                <a16:creationId xmlns:a16="http://schemas.microsoft.com/office/drawing/2014/main" id="{678DBDB7-D50A-C822-E646-6184D1878689}"/>
-              </a:ext>
-            </a:extLst>
-          </p:cNvPr>
-          <p:cNvSpPr/>
-          <p:nvPr/>
-        </p:nvSpPr>
-        <p:spPr bwMode="auto">
-          <a:xfrm>
-            <a:off x="23175975" y="10065532"/>
-            <a:ext cx="1037944" cy="523220"/>
-          </a:xfrm>
-          <a:prstGeom prst="rect">
-            <a:avLst/>
-          </a:prstGeom>
-          <a:solidFill>
-            <a:srgbClr val="262626"/>
-          </a:solidFill>
-          <a:ln w="9525" cap="flat" cmpd="sng" algn="ctr">
-            <a:solidFill>
-              <a:srgbClr val="FF9500"/>
-            </a:solidFill>
-            <a:prstDash val="solid"/>
-            <a:round/>
-            <a:headEnd type="none" w="med" len="med"/>
-            <a:tailEnd type="none" w="med" len="med"/>
-          </a:ln>
-          <a:effectLst/>
-        </p:spPr>
-        <p:txBody>
-          <a:bodyPr vert="horz" wrap="square" lIns="91440" tIns="45720" rIns="91440" bIns="45720" numCol="1" rtlCol="0" anchor="t" anchorCtr="0" compatLnSpc="1">
-            <a:prstTxWarp prst="textNoShape">
-              <a:avLst/>
-            </a:prstTxWarp>
-          </a:bodyPr>
-          <a:lstStyle/>
-          <a:p>
-            <a:pPr marL="0" marR="0" indent="0" algn="ctr" defTabSz="3600450" rtl="0" eaLnBrk="1" fontAlgn="base" latinLnBrk="0" hangingPunct="1">
-              <a:lnSpc>
-                <a:spcPct val="100000"/>
-              </a:lnSpc>
-              <a:spcBef>
-                <a:spcPct val="0"/>
-              </a:spcBef>
-              <a:spcAft>
-                <a:spcPct val="0"/>
-              </a:spcAft>
-              <a:buClrTx/>
-              <a:buSzTx/>
-              <a:buFontTx/>
-              <a:buNone/>
-              <a:tabLst/>
-            </a:pPr>
-            <a:r>
-              <a:rPr kumimoji="0" lang="en-IE" sz="2800" b="0" i="0" u="none" strike="noStrike" cap="none" normalizeH="0" baseline="0" dirty="0">
-                <a:ln>
-                  <a:noFill/>
-                </a:ln>
-                <a:solidFill>
-                  <a:schemeClr val="bg1"/>
-                </a:solidFill>
-                <a:effectLst/>
-                <a:latin typeface="Arial Narrow" charset="0"/>
-              </a:rPr>
-              <a:t>Graph</a:t>
-            </a:r>
-            <a:endParaRPr kumimoji="0" lang="en-IE" sz="2400" b="0" i="0" u="none" strike="noStrike" cap="none" normalizeH="0" baseline="0" dirty="0">
-              <a:ln>
-                <a:noFill/>
-              </a:ln>
-              <a:solidFill>
-                <a:schemeClr val="bg1"/>
-              </a:solidFill>
-              <a:effectLst/>
-              <a:latin typeface="Arial Narrow" charset="0"/>
-            </a:endParaRPr>
-          </a:p>
-        </p:txBody>
-      </p:sp>
-      <p:sp>
-        <p:nvSpPr>
-          <p:cNvPr id="5970" name="Rectangle 5969">
-            <a:extLst>
-              <a:ext uri="{FF2B5EF4-FFF2-40B4-BE49-F238E27FC236}">
-                <a16:creationId xmlns:a16="http://schemas.microsoft.com/office/drawing/2014/main" id="{6111DB17-965B-D3EA-E5C9-4D7D8BACE32E}"/>
-              </a:ext>
-            </a:extLst>
-          </p:cNvPr>
-          <p:cNvSpPr/>
-          <p:nvPr/>
-        </p:nvSpPr>
-        <p:spPr bwMode="auto">
-          <a:xfrm>
-            <a:off x="24297739" y="10062606"/>
-            <a:ext cx="1037944" cy="523220"/>
-          </a:xfrm>
-          <a:prstGeom prst="rect">
-            <a:avLst/>
-          </a:prstGeom>
-          <a:solidFill>
-            <a:srgbClr val="262626"/>
-          </a:solidFill>
-          <a:ln w="9525" cap="flat" cmpd="sng" algn="ctr">
-            <a:solidFill>
-              <a:srgbClr val="FF9500"/>
-            </a:solidFill>
-            <a:prstDash val="solid"/>
-            <a:round/>
-            <a:headEnd type="none" w="med" len="med"/>
-            <a:tailEnd type="none" w="med" len="med"/>
-          </a:ln>
-          <a:effectLst/>
-        </p:spPr>
-        <p:txBody>
-          <a:bodyPr vert="horz" wrap="square" lIns="91440" tIns="45720" rIns="91440" bIns="45720" numCol="1" rtlCol="0" anchor="ctr" anchorCtr="0" compatLnSpc="1">
-            <a:prstTxWarp prst="textNoShape">
-              <a:avLst/>
-            </a:prstTxWarp>
-          </a:bodyPr>
-          <a:lstStyle/>
-          <a:p>
-            <a:pPr marL="0" marR="0" indent="0" algn="ctr" defTabSz="3600450" rtl="0" eaLnBrk="1" fontAlgn="base" latinLnBrk="0" hangingPunct="1">
-              <a:lnSpc>
-                <a:spcPct val="100000"/>
-              </a:lnSpc>
-              <a:spcBef>
-                <a:spcPct val="0"/>
-              </a:spcBef>
-              <a:spcAft>
-                <a:spcPct val="0"/>
-              </a:spcAft>
-              <a:buClrTx/>
-              <a:buSzTx/>
-              <a:buFontTx/>
-              <a:buNone/>
-              <a:tabLst/>
-            </a:pPr>
-            <a:r>
-              <a:rPr kumimoji="0" lang="en-IE" b="0" i="0" u="none" strike="noStrike" cap="none" normalizeH="0" baseline="0" dirty="0">
-                <a:ln>
-                  <a:noFill/>
-                </a:ln>
-                <a:solidFill>
-                  <a:schemeClr val="bg1"/>
-                </a:solidFill>
-                <a:effectLst/>
-                <a:latin typeface="Arial Narrow" charset="0"/>
-              </a:rPr>
-              <a:t>Greedy</a:t>
-            </a:r>
-            <a:endParaRPr kumimoji="0" lang="en-IE" sz="2000" b="0" i="0" u="none" strike="noStrike" cap="none" normalizeH="0" baseline="0" dirty="0">
-              <a:ln>
-                <a:noFill/>
-              </a:ln>
-              <a:solidFill>
-                <a:schemeClr val="bg1"/>
-              </a:solidFill>
-              <a:effectLst/>
-              <a:latin typeface="Arial Narrow" charset="0"/>
-            </a:endParaRPr>
-          </a:p>
-        </p:txBody>
-      </p:sp>
-      <p:sp>
-        <p:nvSpPr>
-          <p:cNvPr id="5971" name="Rectangle 5970">
-            <a:extLst>
-              <a:ext uri="{FF2B5EF4-FFF2-40B4-BE49-F238E27FC236}">
-                <a16:creationId xmlns:a16="http://schemas.microsoft.com/office/drawing/2014/main" id="{8E82FAE0-E23B-2DA9-60B3-645C76329AC3}"/>
-              </a:ext>
-            </a:extLst>
-          </p:cNvPr>
-          <p:cNvSpPr/>
-          <p:nvPr/>
-        </p:nvSpPr>
-        <p:spPr bwMode="auto">
-          <a:xfrm>
-            <a:off x="25454355" y="10065532"/>
-            <a:ext cx="1037944" cy="523220"/>
-          </a:xfrm>
-          <a:prstGeom prst="rect">
-            <a:avLst/>
-          </a:prstGeom>
-          <a:solidFill>
-            <a:srgbClr val="262626"/>
-          </a:solidFill>
-          <a:ln w="9525" cap="flat" cmpd="sng" algn="ctr">
-            <a:solidFill>
-              <a:srgbClr val="FF9500"/>
-            </a:solidFill>
-            <a:prstDash val="solid"/>
-            <a:round/>
-            <a:headEnd type="none" w="med" len="med"/>
-            <a:tailEnd type="none" w="med" len="med"/>
-          </a:ln>
-          <a:effectLst/>
-        </p:spPr>
-        <p:txBody>
-          <a:bodyPr vert="horz" wrap="square" lIns="91440" tIns="45720" rIns="91440" bIns="45720" numCol="1" rtlCol="0" anchor="ctr" anchorCtr="0" compatLnSpc="1">
-            <a:prstTxWarp prst="textNoShape">
-              <a:avLst/>
-            </a:prstTxWarp>
-          </a:bodyPr>
-          <a:lstStyle/>
-          <a:p>
-            <a:pPr marL="0" marR="0" indent="0" algn="ctr" defTabSz="3600450" rtl="0" eaLnBrk="1" fontAlgn="base" latinLnBrk="0" hangingPunct="1">
-              <a:lnSpc>
-                <a:spcPct val="100000"/>
-              </a:lnSpc>
-              <a:spcBef>
-                <a:spcPct val="0"/>
-              </a:spcBef>
-              <a:spcAft>
-                <a:spcPct val="0"/>
-              </a:spcAft>
-              <a:buClrTx/>
-              <a:buSzTx/>
-              <a:buFontTx/>
-              <a:buNone/>
-              <a:tabLst/>
-            </a:pPr>
-            <a:r>
               <a:rPr kumimoji="0" lang="en-IE" sz="1600" b="0" i="0" u="none" strike="noStrike" cap="none" normalizeH="0" baseline="0" dirty="0">
                 <a:ln>
                   <a:noFill/>
@@ -31712,155 +31613,7 @@
                 <a:effectLst/>
                 <a:latin typeface="Arial Narrow" charset="0"/>
               </a:rPr>
-              <a:t>Linked Lists</a:t>
-            </a:r>
-          </a:p>
-        </p:txBody>
-      </p:sp>
-      <p:sp>
-        <p:nvSpPr>
-          <p:cNvPr id="5973" name="Rectangle 5972">
-            <a:extLst>
-              <a:ext uri="{FF2B5EF4-FFF2-40B4-BE49-F238E27FC236}">
-                <a16:creationId xmlns:a16="http://schemas.microsoft.com/office/drawing/2014/main" id="{51F712F5-4AB2-7B36-D0C1-FDBABAC0BD55}"/>
-              </a:ext>
-            </a:extLst>
-          </p:cNvPr>
-          <p:cNvSpPr/>
-          <p:nvPr/>
-        </p:nvSpPr>
-        <p:spPr bwMode="auto">
-          <a:xfrm>
-            <a:off x="26589735" y="10065532"/>
-            <a:ext cx="1037944" cy="523220"/>
-          </a:xfrm>
-          <a:prstGeom prst="rect">
-            <a:avLst/>
-          </a:prstGeom>
-          <a:solidFill>
-            <a:srgbClr val="262626"/>
-          </a:solidFill>
-          <a:ln w="9525" cap="flat" cmpd="sng" algn="ctr">
-            <a:solidFill>
-              <a:srgbClr val="FF9500"/>
-            </a:solidFill>
-            <a:prstDash val="solid"/>
-            <a:round/>
-            <a:headEnd type="none" w="med" len="med"/>
-            <a:tailEnd type="none" w="med" len="med"/>
-          </a:ln>
-          <a:effectLst/>
-        </p:spPr>
-        <p:txBody>
-          <a:bodyPr vert="horz" wrap="square" lIns="91440" tIns="45720" rIns="91440" bIns="45720" numCol="1" rtlCol="0" anchor="ctr" anchorCtr="0" compatLnSpc="1">
-            <a:prstTxWarp prst="textNoShape">
-              <a:avLst/>
-            </a:prstTxWarp>
-          </a:bodyPr>
-          <a:lstStyle/>
-          <a:p>
-            <a:pPr marL="0" marR="0" indent="0" algn="ctr" defTabSz="3600450" rtl="0" eaLnBrk="1" fontAlgn="base" latinLnBrk="0" hangingPunct="1">
-              <a:lnSpc>
-                <a:spcPct val="100000"/>
-              </a:lnSpc>
-              <a:spcBef>
-                <a:spcPct val="0"/>
-              </a:spcBef>
-              <a:spcAft>
-                <a:spcPct val="0"/>
-              </a:spcAft>
-              <a:buClrTx/>
-              <a:buSzTx/>
-              <a:buFontTx/>
-              <a:buNone/>
-              <a:tabLst/>
-            </a:pPr>
-            <a:r>
-              <a:rPr kumimoji="0" lang="en-IE" sz="1600" b="0" i="0" u="none" strike="noStrike" cap="none" normalizeH="0" baseline="0" dirty="0">
-                <a:ln>
-                  <a:noFill/>
-                </a:ln>
-                <a:solidFill>
-                  <a:schemeClr val="bg1"/>
-                </a:solidFill>
-                <a:effectLst/>
-                <a:latin typeface="Arial Narrow" charset="0"/>
-              </a:rPr>
               <a:t>Recursion</a:t>
-            </a:r>
-          </a:p>
-        </p:txBody>
-      </p:sp>
-      <p:sp>
-        <p:nvSpPr>
-          <p:cNvPr id="5977" name="Rectangle 5976">
-            <a:extLst>
-              <a:ext uri="{FF2B5EF4-FFF2-40B4-BE49-F238E27FC236}">
-                <a16:creationId xmlns:a16="http://schemas.microsoft.com/office/drawing/2014/main" id="{199EB09E-DA68-58F7-B240-1CF84E2F20FB}"/>
-              </a:ext>
-            </a:extLst>
-          </p:cNvPr>
-          <p:cNvSpPr/>
-          <p:nvPr/>
-        </p:nvSpPr>
-        <p:spPr bwMode="auto">
-          <a:xfrm>
-            <a:off x="22048215" y="10065303"/>
-            <a:ext cx="1037944" cy="523220"/>
-          </a:xfrm>
-          <a:prstGeom prst="rect">
-            <a:avLst/>
-          </a:prstGeom>
-          <a:solidFill>
-            <a:srgbClr val="262626"/>
-          </a:solidFill>
-          <a:ln w="9525" cap="flat" cmpd="sng" algn="ctr">
-            <a:solidFill>
-              <a:srgbClr val="FF9500"/>
-            </a:solidFill>
-            <a:prstDash val="solid"/>
-            <a:round/>
-            <a:headEnd type="none" w="med" len="med"/>
-            <a:tailEnd type="none" w="med" len="med"/>
-          </a:ln>
-          <a:effectLst/>
-        </p:spPr>
-        <p:txBody>
-          <a:bodyPr vert="horz" wrap="square" lIns="91440" tIns="45720" rIns="91440" bIns="45720" numCol="1" rtlCol="0" anchor="ctr" anchorCtr="0" compatLnSpc="1">
-            <a:prstTxWarp prst="textNoShape">
-              <a:avLst/>
-            </a:prstTxWarp>
-          </a:bodyPr>
-          <a:lstStyle/>
-          <a:p>
-            <a:pPr marL="0" marR="0" indent="0" algn="ctr" defTabSz="3600450" rtl="0" eaLnBrk="1" fontAlgn="base" latinLnBrk="0" hangingPunct="1">
-              <a:lnSpc>
-                <a:spcPct val="100000"/>
-              </a:lnSpc>
-              <a:spcBef>
-                <a:spcPct val="0"/>
-              </a:spcBef>
-              <a:spcAft>
-                <a:spcPct val="0"/>
-              </a:spcAft>
-              <a:buClrTx/>
-              <a:buSzTx/>
-              <a:buFontTx/>
-              <a:buNone/>
-              <a:tabLst/>
-            </a:pPr>
-            <a:r>
-              <a:rPr kumimoji="0" lang="en-IE" sz="1600" b="0" i="0" u="none" strike="noStrike" cap="none" normalizeH="0" baseline="0" dirty="0">
-                <a:ln>
-                  <a:noFill/>
-                </a:ln>
-                <a:solidFill>
-                  <a:schemeClr val="bg1"/>
-                </a:solidFill>
-                <a:effectLst/>
-                <a:latin typeface="Arial Narrow" charset="0"/>
-              </a:rPr>
-              <a:t>Sliding Window</a:t>
             </a:r>
           </a:p>
         </p:txBody>
@@ -32805,7 +32558,7 @@
                 </a:solidFill>
                 <a:latin typeface="Arial"/>
               </a:rPr>
-              <a:t>Future Works</a:t>
+              <a:t>Future Work</a:t>
             </a:r>
           </a:p>
         </p:txBody>
@@ -33099,7 +32852,7 @@
                   <a:schemeClr val="bg1"/>
                 </a:solidFill>
               </a:rPr>
-              <a:t>GPT-4o-mini–Technical Report.</a:t>
+              <a:t>GPT-4o-mini Technical Report.</a:t>
             </a:r>
             <a:r>
               <a:rPr lang="en-GB" sz="2800" dirty="0">

</xml_diff>